<commit_message>
update about added swiper
</commit_message>
<xml_diff>
--- a/MKnet.Landing.Strategy/Utils/MKnET imagenes Template.pptx
+++ b/MKnet.Landing.Strategy/Utils/MKnET imagenes Template.pptx
@@ -5,10 +5,10 @@
     <p:sldMasterId id="2147483648" r:id="rId1"/>
   </p:sldMasterIdLst>
   <p:sldIdLst>
-    <p:sldId id="259" r:id="rId2"/>
-    <p:sldId id="256" r:id="rId3"/>
-    <p:sldId id="258" r:id="rId4"/>
-    <p:sldId id="257" r:id="rId5"/>
+    <p:sldId id="256" r:id="rId2"/>
+    <p:sldId id="258" r:id="rId3"/>
+    <p:sldId id="257" r:id="rId4"/>
+    <p:sldId id="259" r:id="rId5"/>
   </p:sldIdLst>
   <p:sldSz cx="12192000" cy="6858000"/>
   <p:notesSz cx="6858000" cy="9144000"/>
@@ -3336,273 +3336,6 @@
 <file path=ppt/slides/slide1.xml><?xml version="1.0" encoding="utf-8"?>
 <p:sld xmlns:a="http://schemas.openxmlformats.org/drawingml/2006/main" xmlns:r="http://schemas.openxmlformats.org/officeDocument/2006/relationships" xmlns:p="http://schemas.openxmlformats.org/presentationml/2006/main">
   <p:cSld>
-    <p:bg>
-      <p:bgPr>
-        <a:solidFill>
-          <a:schemeClr val="bg2">
-            <a:lumMod val="50000"/>
-          </a:schemeClr>
-        </a:solidFill>
-        <a:effectLst/>
-      </p:bgPr>
-    </p:bg>
-    <p:spTree>
-      <p:nvGrpSpPr>
-        <p:cNvPr id="1" name=""/>
-        <p:cNvGrpSpPr/>
-        <p:nvPr/>
-      </p:nvGrpSpPr>
-      <p:grpSpPr>
-        <a:xfrm>
-          <a:off x="0" y="0"/>
-          <a:ext cx="0" cy="0"/>
-          <a:chOff x="0" y="0"/>
-          <a:chExt cx="0" cy="0"/>
-        </a:xfrm>
-      </p:grpSpPr>
-      <p:grpSp>
-        <p:nvGrpSpPr>
-          <p:cNvPr id="8" name="Group 7">
-            <a:extLst>
-              <a:ext uri="{FF2B5EF4-FFF2-40B4-BE49-F238E27FC236}">
-                <a16:creationId xmlns:a16="http://schemas.microsoft.com/office/drawing/2014/main" id="{E0701448-A937-4B9A-8AD9-36A4611657C9}"/>
-              </a:ext>
-            </a:extLst>
-          </p:cNvPr>
-          <p:cNvGrpSpPr/>
-          <p:nvPr/>
-        </p:nvGrpSpPr>
-        <p:grpSpPr>
-          <a:xfrm>
-            <a:off x="527993" y="705542"/>
-            <a:ext cx="10810567" cy="2078905"/>
-            <a:chOff x="2097713" y="1782222"/>
-            <a:chExt cx="10810567" cy="2078905"/>
-          </a:xfrm>
-        </p:grpSpPr>
-        <p:grpSp>
-          <p:nvGrpSpPr>
-            <p:cNvPr id="2" name="Group 1">
-              <a:extLst>
-                <a:ext uri="{FF2B5EF4-FFF2-40B4-BE49-F238E27FC236}">
-                  <a16:creationId xmlns:a16="http://schemas.microsoft.com/office/drawing/2014/main" id="{DA8C4E31-5ADE-425E-AA0E-085683138F27}"/>
-                </a:ext>
-              </a:extLst>
-            </p:cNvPr>
-            <p:cNvGrpSpPr/>
-            <p:nvPr/>
-          </p:nvGrpSpPr>
-          <p:grpSpPr>
-            <a:xfrm>
-              <a:off x="2097713" y="1782222"/>
-              <a:ext cx="7348746" cy="2078905"/>
-              <a:chOff x="2097713" y="1782222"/>
-              <a:chExt cx="7348746" cy="2078905"/>
-            </a:xfrm>
-          </p:grpSpPr>
-          <p:sp>
-            <p:nvSpPr>
-              <p:cNvPr id="4" name="Title 1">
-                <a:extLst>
-                  <a:ext uri="{FF2B5EF4-FFF2-40B4-BE49-F238E27FC236}">
-                    <a16:creationId xmlns:a16="http://schemas.microsoft.com/office/drawing/2014/main" id="{F451CB52-16CC-47DE-B2F2-D59451547C99}"/>
-                  </a:ext>
-                </a:extLst>
-              </p:cNvPr>
-              <p:cNvSpPr txBox="1">
-                <a:spLocks/>
-              </p:cNvSpPr>
-              <p:nvPr/>
-            </p:nvSpPr>
-            <p:spPr>
-              <a:xfrm>
-                <a:off x="3961230" y="1782222"/>
-                <a:ext cx="5485229" cy="1905265"/>
-              </a:xfrm>
-              <a:prstGeom prst="rect">
-                <a:avLst/>
-              </a:prstGeom>
-            </p:spPr>
-            <p:txBody>
-              <a:bodyPr vert="horz" lIns="91440" tIns="45720" rIns="91440" bIns="45720" rtlCol="0" anchor="ctr">
-                <a:normAutofit fontScale="90000"/>
-              </a:bodyPr>
-              <a:lstStyle>
-                <a:lvl1pPr algn="l" defTabSz="914400" rtl="0" eaLnBrk="1" latinLnBrk="0" hangingPunct="1">
-                  <a:lnSpc>
-                    <a:spcPct val="90000"/>
-                  </a:lnSpc>
-                  <a:spcBef>
-                    <a:spcPct val="0"/>
-                  </a:spcBef>
-                  <a:buNone/>
-                  <a:defRPr sz="4400" kern="1200">
-                    <a:solidFill>
-                      <a:schemeClr val="tx1"/>
-                    </a:solidFill>
-                    <a:latin typeface="+mj-lt"/>
-                    <a:ea typeface="+mj-ea"/>
-                    <a:cs typeface="+mj-cs"/>
-                  </a:defRPr>
-                </a:lvl1pPr>
-              </a:lstStyle>
-              <a:p>
-                <a:r>
-                  <a:rPr lang="en-US" sz="11500" dirty="0" err="1">
-                    <a:solidFill>
-                      <a:srgbClr val="EC1C23"/>
-                    </a:solidFill>
-                    <a:latin typeface="Arial Black" panose="020B0A04020102020204" pitchFamily="34" charset="0"/>
-                  </a:rPr>
-                  <a:t>MK</a:t>
-                </a:r>
-                <a:r>
-                  <a:rPr lang="en-US" sz="11500" dirty="0" err="1">
-                    <a:solidFill>
-                      <a:srgbClr val="FAAF3A"/>
-                    </a:solidFill>
-                    <a:latin typeface="Arial Black" panose="020B0A04020102020204" pitchFamily="34" charset="0"/>
-                  </a:rPr>
-                  <a:t>nET</a:t>
-                </a:r>
-                <a:endParaRPr lang="es-MX" sz="11500" dirty="0">
-                  <a:solidFill>
-                    <a:srgbClr val="FAAF3A"/>
-                  </a:solidFill>
-                  <a:latin typeface="Arial Black" panose="020B0A04020102020204" pitchFamily="34" charset="0"/>
-                </a:endParaRPr>
-              </a:p>
-            </p:txBody>
-          </p:sp>
-          <p:pic>
-            <p:nvPicPr>
-              <p:cNvPr id="5" name="Picture 4">
-                <a:extLst>
-                  <a:ext uri="{FF2B5EF4-FFF2-40B4-BE49-F238E27FC236}">
-                    <a16:creationId xmlns:a16="http://schemas.microsoft.com/office/drawing/2014/main" id="{EE450F71-4193-4481-8D2E-0C1AB5B2B1B3}"/>
-                  </a:ext>
-                </a:extLst>
-              </p:cNvPr>
-              <p:cNvPicPr>
-                <a:picLocks noChangeAspect="1"/>
-              </p:cNvPicPr>
-              <p:nvPr/>
-            </p:nvPicPr>
-            <p:blipFill>
-              <a:blip r:embed="rId2">
-                <a:extLst>
-                  <a:ext uri="{28A0092B-C50C-407E-A947-70E740481C1C}">
-                    <a14:useLocalDpi xmlns:a14="http://schemas.microsoft.com/office/drawing/2010/main" val="0"/>
-                  </a:ext>
-                </a:extLst>
-              </a:blip>
-              <a:stretch>
-                <a:fillRect/>
-              </a:stretch>
-            </p:blipFill>
-            <p:spPr>
-              <a:xfrm>
-                <a:off x="2097713" y="1955861"/>
-                <a:ext cx="1905266" cy="1905266"/>
-              </a:xfrm>
-              <a:prstGeom prst="rect">
-                <a:avLst/>
-              </a:prstGeom>
-            </p:spPr>
-          </p:pic>
-        </p:grpSp>
-        <p:sp>
-          <p:nvSpPr>
-            <p:cNvPr id="7" name="TextBox 6">
-              <a:extLst>
-                <a:ext uri="{FF2B5EF4-FFF2-40B4-BE49-F238E27FC236}">
-                  <a16:creationId xmlns:a16="http://schemas.microsoft.com/office/drawing/2014/main" id="{8634D6CA-45E1-4440-B863-7CB57760EF2B}"/>
-                </a:ext>
-              </a:extLst>
-            </p:cNvPr>
-            <p:cNvSpPr txBox="1"/>
-            <p:nvPr/>
-          </p:nvSpPr>
-          <p:spPr>
-            <a:xfrm>
-              <a:off x="4032668" y="3131818"/>
-              <a:ext cx="8875612" cy="584775"/>
-            </a:xfrm>
-            <a:prstGeom prst="rect">
-              <a:avLst/>
-            </a:prstGeom>
-            <a:noFill/>
-          </p:spPr>
-          <p:txBody>
-            <a:bodyPr wrap="square">
-              <a:spAutoFit/>
-            </a:bodyPr>
-            <a:lstStyle/>
-            <a:p>
-              <a:r>
-                <a:rPr lang="es-MX" sz="3200" dirty="0">
-                  <a:solidFill>
-                    <a:schemeClr val="bg1"/>
-                  </a:solidFill>
-                  <a:latin typeface="Arial Black" panose="020B0A04020102020204" pitchFamily="34" charset="0"/>
-                </a:rPr>
-                <a:t>Punto a punto, hacemos la diferencia.</a:t>
-              </a:r>
-            </a:p>
-          </p:txBody>
-        </p:sp>
-      </p:grpSp>
-      <p:pic>
-        <p:nvPicPr>
-          <p:cNvPr id="13" name="Picture 12">
-            <a:extLst>
-              <a:ext uri="{FF2B5EF4-FFF2-40B4-BE49-F238E27FC236}">
-                <a16:creationId xmlns:a16="http://schemas.microsoft.com/office/drawing/2014/main" id="{04A220E6-CFE0-49CE-9811-14931ABDC933}"/>
-              </a:ext>
-            </a:extLst>
-          </p:cNvPr>
-          <p:cNvPicPr>
-            <a:picLocks noChangeAspect="1"/>
-          </p:cNvPicPr>
-          <p:nvPr/>
-        </p:nvPicPr>
-        <p:blipFill rotWithShape="1">
-          <a:blip r:embed="rId3">
-            <a:extLst>
-              <a:ext uri="{28A0092B-C50C-407E-A947-70E740481C1C}">
-                <a14:useLocalDpi xmlns:a14="http://schemas.microsoft.com/office/drawing/2010/main" val="0"/>
-              </a:ext>
-            </a:extLst>
-          </a:blip>
-          <a:srcRect t="14915" b="11077"/>
-          <a:stretch/>
-        </p:blipFill>
-        <p:spPr>
-          <a:xfrm>
-            <a:off x="691427" y="3726180"/>
-            <a:ext cx="10809145" cy="2057400"/>
-          </a:xfrm>
-          <a:prstGeom prst="rect">
-            <a:avLst/>
-          </a:prstGeom>
-        </p:spPr>
-      </p:pic>
-    </p:spTree>
-    <p:extLst>
-      <p:ext uri="{BB962C8B-B14F-4D97-AF65-F5344CB8AC3E}">
-        <p14:creationId xmlns:p14="http://schemas.microsoft.com/office/powerpoint/2010/main" val="2291501693"/>
-      </p:ext>
-    </p:extLst>
-  </p:cSld>
-  <p:clrMapOvr>
-    <a:masterClrMapping/>
-  </p:clrMapOvr>
-</p:sld>
-</file>
-
-<file path=ppt/slides/slide2.xml><?xml version="1.0" encoding="utf-8"?>
-<p:sld xmlns:a="http://schemas.openxmlformats.org/drawingml/2006/main" xmlns:r="http://schemas.openxmlformats.org/officeDocument/2006/relationships" xmlns:p="http://schemas.openxmlformats.org/presentationml/2006/main">
-  <p:cSld>
     <p:spTree>
       <p:nvGrpSpPr>
         <p:cNvPr id="1" name=""/>
@@ -3962,7 +3695,7 @@
 </p:sld>
 </file>
 
-<file path=ppt/slides/slide3.xml><?xml version="1.0" encoding="utf-8"?>
+<file path=ppt/slides/slide2.xml><?xml version="1.0" encoding="utf-8"?>
 <p:sld xmlns:a="http://schemas.openxmlformats.org/drawingml/2006/main" xmlns:r="http://schemas.openxmlformats.org/officeDocument/2006/relationships" xmlns:p="http://schemas.openxmlformats.org/presentationml/2006/main">
   <p:cSld>
     <p:spTree>
@@ -4100,7 +3833,7 @@
 </p:sld>
 </file>
 
-<file path=ppt/slides/slide4.xml><?xml version="1.0" encoding="utf-8"?>
+<file path=ppt/slides/slide3.xml><?xml version="1.0" encoding="utf-8"?>
 <p:sld xmlns:a="http://schemas.openxmlformats.org/drawingml/2006/main" xmlns:r="http://schemas.openxmlformats.org/officeDocument/2006/relationships" xmlns:p="http://schemas.openxmlformats.org/presentationml/2006/main">
   <p:cSld>
     <p:spTree>
@@ -4452,6 +4185,107 @@
     <p:extLst>
       <p:ext uri="{BB962C8B-B14F-4D97-AF65-F5344CB8AC3E}">
         <p14:creationId xmlns:p14="http://schemas.microsoft.com/office/powerpoint/2010/main" val="1334241255"/>
+      </p:ext>
+    </p:extLst>
+  </p:cSld>
+  <p:clrMapOvr>
+    <a:masterClrMapping/>
+  </p:clrMapOvr>
+</p:sld>
+</file>
+
+<file path=ppt/slides/slide4.xml><?xml version="1.0" encoding="utf-8"?>
+<p:sld xmlns:a="http://schemas.openxmlformats.org/drawingml/2006/main" xmlns:r="http://schemas.openxmlformats.org/officeDocument/2006/relationships" xmlns:p="http://schemas.openxmlformats.org/presentationml/2006/main">
+  <p:cSld>
+    <p:spTree>
+      <p:nvGrpSpPr>
+        <p:cNvPr id="1" name=""/>
+        <p:cNvGrpSpPr/>
+        <p:nvPr/>
+      </p:nvGrpSpPr>
+      <p:grpSpPr>
+        <a:xfrm>
+          <a:off x="0" y="0"/>
+          <a:ext cx="0" cy="0"/>
+          <a:chOff x="0" y="0"/>
+          <a:chExt cx="0" cy="0"/>
+        </a:xfrm>
+      </p:grpSpPr>
+      <p:pic>
+        <p:nvPicPr>
+          <p:cNvPr id="7" name="Picture 6">
+            <a:extLst>
+              <a:ext uri="{FF2B5EF4-FFF2-40B4-BE49-F238E27FC236}">
+                <a16:creationId xmlns:a16="http://schemas.microsoft.com/office/drawing/2014/main" id="{0D3CF5CD-5356-426A-A4B5-686800A81EA9}"/>
+              </a:ext>
+            </a:extLst>
+          </p:cNvPr>
+          <p:cNvPicPr>
+            <a:picLocks noChangeAspect="1"/>
+          </p:cNvPicPr>
+          <p:nvPr/>
+        </p:nvPicPr>
+        <p:blipFill>
+          <a:blip r:embed="rId2">
+            <a:extLst>
+              <a:ext uri="{28A0092B-C50C-407E-A947-70E740481C1C}">
+                <a14:useLocalDpi xmlns:a14="http://schemas.microsoft.com/office/drawing/2010/main" val="0"/>
+              </a:ext>
+            </a:extLst>
+          </a:blip>
+          <a:srcRect t="5578" b="5578"/>
+          <a:stretch/>
+        </p:blipFill>
+        <p:spPr>
+          <a:xfrm>
+            <a:off x="0" y="0"/>
+            <a:ext cx="5144756" cy="6858000"/>
+          </a:xfrm>
+          <a:prstGeom prst="rect">
+            <a:avLst/>
+          </a:prstGeom>
+        </p:spPr>
+      </p:pic>
+      <p:pic>
+        <p:nvPicPr>
+          <p:cNvPr id="5" name="Picture 4">
+            <a:extLst>
+              <a:ext uri="{FF2B5EF4-FFF2-40B4-BE49-F238E27FC236}">
+                <a16:creationId xmlns:a16="http://schemas.microsoft.com/office/drawing/2014/main" id="{87756D78-3AF5-4A17-AC84-68719DD620C9}"/>
+              </a:ext>
+            </a:extLst>
+          </p:cNvPr>
+          <p:cNvPicPr>
+            <a:picLocks noChangeAspect="1"/>
+          </p:cNvPicPr>
+          <p:nvPr/>
+        </p:nvPicPr>
+        <p:blipFill>
+          <a:blip r:embed="rId3">
+            <a:extLst>
+              <a:ext uri="{28A0092B-C50C-407E-A947-70E740481C1C}">
+                <a14:useLocalDpi xmlns:a14="http://schemas.microsoft.com/office/drawing/2010/main" val="0"/>
+              </a:ext>
+            </a:extLst>
+          </a:blip>
+          <a:stretch>
+            <a:fillRect/>
+          </a:stretch>
+        </p:blipFill>
+        <p:spPr>
+          <a:xfrm>
+            <a:off x="5766950" y="0"/>
+            <a:ext cx="5144756" cy="6858000"/>
+          </a:xfrm>
+          <a:prstGeom prst="rect">
+            <a:avLst/>
+          </a:prstGeom>
+        </p:spPr>
+      </p:pic>
+    </p:spTree>
+    <p:extLst>
+      <p:ext uri="{BB962C8B-B14F-4D97-AF65-F5344CB8AC3E}">
+        <p14:creationId xmlns:p14="http://schemas.microsoft.com/office/powerpoint/2010/main" val="430580420"/>
       </p:ext>
     </p:extLst>
   </p:cSld>

</xml_diff>